<commit_message>
Confirm the NA Q4 freeze and add an illustrative Wave-1 planning range
Rachel Kim's eight-week NA payment-routing/approval-workflow freeze and
BU CFO sign-off requirement were implied but never stated as a binding
constraint; they're now explicit in the payment pilot charter, risk
register (R031), decision log, and the steering-deck roadmap (Slide 10,
regenerated PPTX/PDF). The validation case also gains a clearly
ANALYST-ASSUMPTION conservative/base/upside planning range (cost,
benefit-realization timing, ramp-up, duration, sensitivities) so the
zero-recognized-value control boundary stops doubling as the only
economic narrative, without touching recognized_value_usd itself.
</commit_message>
<xml_diff>
--- a/deliverables/working/week_3/W3_interim_steering_deck.pptx
+++ b/deliverables/working/week_3/W3_interim_steering_deck.pptx
@@ -6092,7 +6092,7 @@
                 </a:solidFill>
                 <a:latin typeface="Barlow"/>
               </a:rPr>
-              <a:t>Lock baselines and target rules; return with stop, extend-evidence, or a later bounded-pilot recommendation.</a:t>
+              <a:t>Lock baselines and target rules; return with stop, extend-evidence, or a later bounded-pilot recommendation, subject to the confirmed NA Q4 freeze below.</a:t>
             </a:r>
           </a:p>
         </p:txBody>
@@ -6105,14 +6105,14 @@
         </p:nvSpPr>
         <p:spPr>
           <a:xfrm>
-            <a:off x="381000" y="4343400"/>
-            <a:ext cx="8382000" cy="342900"/>
-          </a:xfrm>
-          <a:prstGeom prst="rect">
-            <a:avLst/>
-          </a:prstGeom>
-          <a:solidFill>
-            <a:srgbClr val="1D2D3D"/>
+            <a:off x="381000" y="3759200"/>
+            <a:ext cx="8382000" cy="431800"/>
+          </a:xfrm>
+          <a:prstGeom prst="rect">
+            <a:avLst/>
+          </a:prstGeom>
+          <a:solidFill>
+            <a:srgbClr val="8A5E1E"/>
           </a:solidFill>
           <a:ln>
             <a:noFill/>
@@ -6147,7 +6147,7 @@
         </p:nvSpPr>
         <p:spPr>
           <a:xfrm>
-            <a:off x="508000" y="4445000"/>
+            <a:off x="508000" y="3860800"/>
             <a:ext cx="1219200" cy="177800"/>
           </a:xfrm>
           <a:prstGeom prst="rect">
@@ -6169,11 +6169,11 @@
             <a:r>
               <a:rPr sz="750" b="1" spc="140">
                 <a:solidFill>
-                  <a:srgbClr val="5980A6"/>
-                </a:solidFill>
-                <a:latin typeface="Barlow"/>
-              </a:rPr>
-              <a:t>DECISIONS NOW</a:t>
+                  <a:srgbClr val="1D2D3D"/>
+                </a:solidFill>
+                <a:latin typeface="Barlow"/>
+              </a:rPr>
+              <a:t>NA Q4 FREEZE</a:t>
             </a:r>
           </a:p>
         </p:txBody>
@@ -6186,8 +6186,8 @@
         </p:nvSpPr>
         <p:spPr>
           <a:xfrm>
-            <a:off x="1803400" y="4432300"/>
-            <a:ext cx="6807200" cy="190500"/>
+            <a:off x="1803400" y="3848100"/>
+            <a:ext cx="6807200" cy="279400"/>
           </a:xfrm>
           <a:prstGeom prst="rect">
             <a:avLst/>
@@ -6215,6 +6215,129 @@
                 </a:solidFill>
                 <a:latin typeface="Barlow"/>
               </a:rPr>
+              <a:t>Confirmed: no NA payment-routing/approval-workflow production change for 8 weeks around peak; any NA production change needs BU CFO sign-off — earliest NA production start is Month 5.</a:t>
+            </a:r>
+          </a:p>
+        </p:txBody>
+      </p:sp>
+      <p:sp>
+        <p:nvSpPr>
+          <p:cNvPr id="30" name="Rectangle 29"/>
+          <p:cNvSpPr/>
+          <p:nvPr/>
+        </p:nvSpPr>
+        <p:spPr>
+          <a:xfrm>
+            <a:off x="381000" y="4229100"/>
+            <a:ext cx="8382000" cy="342900"/>
+          </a:xfrm>
+          <a:prstGeom prst="rect">
+            <a:avLst/>
+          </a:prstGeom>
+          <a:solidFill>
+            <a:srgbClr val="1D2D3D"/>
+          </a:solidFill>
+          <a:ln>
+            <a:noFill/>
+          </a:ln>
+          <a:effectLst/>
+        </p:spPr>
+        <p:style>
+          <a:lnRef idx="1">
+            <a:schemeClr val="accent1"/>
+          </a:lnRef>
+          <a:fillRef idx="3">
+            <a:schemeClr val="accent1"/>
+          </a:fillRef>
+          <a:effectRef idx="2">
+            <a:schemeClr val="accent1"/>
+          </a:effectRef>
+          <a:fontRef idx="minor">
+            <a:schemeClr val="lt1"/>
+          </a:fontRef>
+        </p:style>
+        <p:txBody>
+          <a:bodyPr rtlCol="0" anchor="ctr"/>
+          <a:lstStyle/>
+          <a:p/>
+        </p:txBody>
+      </p:sp>
+      <p:sp>
+        <p:nvSpPr>
+          <p:cNvPr id="31" name="TextBox 30"/>
+          <p:cNvSpPr txBox="1"/>
+          <p:nvPr/>
+        </p:nvSpPr>
+        <p:spPr>
+          <a:xfrm>
+            <a:off x="508000" y="4330700"/>
+            <a:ext cx="1219200" cy="177800"/>
+          </a:xfrm>
+          <a:prstGeom prst="rect">
+            <a:avLst/>
+          </a:prstGeom>
+          <a:noFill/>
+        </p:spPr>
+        <p:txBody>
+          <a:bodyPr wrap="square" lIns="0" rIns="0" tIns="0" bIns="0" anchor="t">
+            <a:spAutoFit/>
+          </a:bodyPr>
+          <a:lstStyle/>
+          <a:p>
+            <a:pPr algn="l">
+              <a:spcAft>
+                <a:spcPts val="0"/>
+              </a:spcAft>
+            </a:pPr>
+            <a:r>
+              <a:rPr sz="750" b="1" spc="140">
+                <a:solidFill>
+                  <a:srgbClr val="5980A6"/>
+                </a:solidFill>
+                <a:latin typeface="Barlow"/>
+              </a:rPr>
+              <a:t>DECISIONS NOW</a:t>
+            </a:r>
+          </a:p>
+        </p:txBody>
+      </p:sp>
+      <p:sp>
+        <p:nvSpPr>
+          <p:cNvPr id="32" name="TextBox 31"/>
+          <p:cNvSpPr txBox="1"/>
+          <p:nvPr/>
+        </p:nvSpPr>
+        <p:spPr>
+          <a:xfrm>
+            <a:off x="1803400" y="4318000"/>
+            <a:ext cx="6807200" cy="190500"/>
+          </a:xfrm>
+          <a:prstGeom prst="rect">
+            <a:avLst/>
+          </a:prstGeom>
+          <a:noFill/>
+        </p:spPr>
+        <p:txBody>
+          <a:bodyPr wrap="square" lIns="0" rIns="0" tIns="0" bIns="0" anchor="ctr">
+            <a:spAutoFit/>
+          </a:bodyPr>
+          <a:lstStyle/>
+          <a:p>
+            <a:pPr algn="l">
+              <a:lnSpc>
+                <a:spcPct val="115000"/>
+              </a:lnSpc>
+              <a:spcAft>
+                <a:spcPts val="0"/>
+              </a:spcAft>
+            </a:pPr>
+            <a:r>
+              <a:rPr sz="850" b="0">
+                <a:solidFill>
+                  <a:srgbClr val="FFFFFF"/>
+                </a:solidFill>
+                <a:latin typeface="Barlow"/>
+              </a:rPr>
               <a:t>Endorse the direction · assign owners · approve the evidence timebox · reserve all launch, spend, value, and scale decisions.</a:t>
             </a:r>
           </a:p>
@@ -6222,7 +6345,7 @@
       </p:sp>
       <p:sp>
         <p:nvSpPr>
-          <p:cNvPr id="30" name="TextBox 29"/>
+          <p:cNvPr id="33" name="TextBox 32"/>
           <p:cNvSpPr txBox="1"/>
           <p:nvPr/>
         </p:nvSpPr>
@@ -6254,7 +6377,7 @@
                 </a:solidFill>
                 <a:latin typeface="Barlow"/>
               </a:rPr>
-              <a:t>Source: W3 future-state operating model; W3 pilot charters; W3 business case and strategic options.</a:t>
+              <a:t>Source: W3 future-state operating model; W3 pilot charters; W3 business case and strategic options; W3 decision log and risk register (R031).</a:t>
             </a:r>
           </a:p>
         </p:txBody>

</xml_diff>